<commit_message>
Update presentation: LangGraph checkpointer is Postgres, not sqlite
Slide 10's orchestration diagram said "sqlite-checkpointed" for the
admin_approval node, left over from before the checkpointer was
switched to the app's existing Postgres database.

Co-Authored-By: Claude Sonnet 5 <noreply@anthropic.com>
</commit_message>
<xml_diff>
--- a/docs/presentation.pptx
+++ b/docs/presentation.pptx
@@ -118,41 +118,41 @@
   <p:extLst>
     <p:ext uri="{521415D9-36F7-43E2-AB2F-B90AF26B5E84}">
       <p14:sectionLst xmlns:p14="http://schemas.microsoft.com/office/powerpoint/2010/main">
-        <p14:section name="Introduction" id="{6f4c74a2-73ba-6539-4255-39d70c994fa6}">
+        <p14:section name="Introduction" id="{a9fe0de1-f20d-65b0-7541-18c2297b6454}">
           <p14:sldIdLst>
             <p14:sldId id="256"/>
             <p14:sldId id="257"/>
             <p14:sldId id="258"/>
           </p14:sldIdLst>
         </p14:section>
-        <p14:section name="Stage 1 — RAG" id="{df83f2f3-f518-233a-c808-fdbc615dd231}">
+        <p14:section name="Stage 1 — RAG" id="{1bf7d64f-2d2a-bbea-b722-6da16dc4a3e0}">
           <p14:sldIdLst>
             <p14:sldId id="259"/>
             <p14:sldId id="260"/>
           </p14:sldIdLst>
         </p14:section>
-        <p14:section name="In action" id="{2eb14f61-b1ef-efca-e8f1-5172ab9a8920}">
+        <p14:section name="In action" id="{7c54c093-785d-d71d-0380-739f193160c2}">
           <p14:sldIdLst>
             <p14:sldId id="261"/>
             <p14:sldId id="262"/>
           </p14:sldIdLst>
         </p14:section>
-        <p14:section name="Stage 2 — Human-in-the-loop" id="{181bf89c-2062-0778-ef97-4a13ffa0c29c}">
+        <p14:section name="Stage 2 — Human-in-the-loop" id="{01fe570f-62dd-105d-bf09-e1c915b932ef}">
           <p14:sldIdLst>
             <p14:sldId id="263"/>
           </p14:sldIdLst>
         </p14:section>
-        <p14:section name="Stage 3 — MCP server" id="{f5bd0a09-b5b9-5307-7080-76cf241ad36c}">
+        <p14:section name="Stage 3 — MCP server" id="{f8446826-963b-7aa1-e230-150140159f42}">
           <p14:sldIdLst>
             <p14:sldId id="264"/>
           </p14:sldIdLst>
         </p14:section>
-        <p14:section name="Stage 4 — Orchestration" id="{8d6383a5-3dfe-5423-3524-04932bfefd6a}">
+        <p14:section name="Stage 4 — Orchestration" id="{d494e626-e859-4659-bcd9-a977fb10b207}">
           <p14:sldIdLst>
             <p14:sldId id="265"/>
           </p14:sldIdLst>
         </p14:section>
-        <p14:section name="Testing" id="{29789db1-92ed-beaa-5450-f6355fd758bc}">
+        <p14:section name="Testing" id="{16bf9296-67c8-c460-474d-6822690e8f76}">
           <p14:sldIdLst>
             <p14:sldId id="266"/>
             <p14:sldId id="267"/>
@@ -2501,7 +2501,7 @@
                 <a:ea typeface="Calibri" pitchFamily="34" charset="-122"/>
                 <a:cs typeface="Calibri" pitchFamily="34" charset="-120"/>
               </a:rPr>
-              <a:t>sqlite-checkpointed</a:t>
+              <a:t>Postgres-checkpointed</a:t>
             </a:r>
             <a:endParaRPr lang="en-US" sz="1000" dirty="0"/>
           </a:p>

</xml_diff>

<commit_message>
Presentation: fresh screenshots of the current UI
Slides 6-8 now show the live app as it is: an answer with cited sources,
the review with free spaces and Confirm / Cancel, the "Reservation
approved" pop-up, and the admin console with the admin agent's summary.
Slide 7's title and captions match the new images.

Co-Authored-By: Claude Opus 5.5 <noreply@anthropic.com>
</commit_message>
<xml_diff>
--- a/docs/presentation.pptx
+++ b/docs/presentation.pptx
@@ -7947,7 +7947,7 @@
                 <a:ea typeface="Cambria" pitchFamily="34" charset="-122"/>
                 <a:cs typeface="Cambria" pitchFamily="34" charset="-120"/>
               </a:rPr>
-              <a:t>From review to a pending reservation</a:t>
+              <a:t>From review to an approved reservation</a:t>
             </a:r>
             <a:endParaRPr lang="en-US" sz="3000" dirty="0"/>
           </a:p>
@@ -8043,7 +8043,7 @@
                 <a:ea typeface="Calibri" pitchFamily="34" charset="-122"/>
                 <a:cs typeface="Calibri" pitchFamily="34" charset="-120"/>
               </a:rPr>
-              <a:t>prepare_reservation's review</a:t>
+              <a:t>prepare_reservation's review, with Confirm / Cancel</a:t>
             </a:r>
             <a:endParaRPr lang="en-US" sz="1100" dirty="0"/>
           </a:p>
@@ -8139,7 +8139,7 @@
                 <a:ea typeface="Calibri" pitchFamily="34" charset="-122"/>
                 <a:cs typeface="Calibri" pitchFamily="34" charset="-120"/>
               </a:rPr>
-              <a:t>Confirm → pending, awaiting the admin</a:t>
+              <a:t>Confirm → admin approves → pop-up in the chat</a:t>
             </a:r>
             <a:endParaRPr lang="en-US" sz="1100" dirty="0"/>
           </a:p>

</xml_diff>

<commit_message>
Export the LangGraph diagrams to docs and the presentation
- scripts/export_graph.py builds the graphs as the app does (stand-in model,
  in-memory checkpointer - no services needed) and writes docs/graph.md:
  Mermaid diagrams of ParkingGraph and of the user and admin agents, whose
  middleware (incl. the human-in-the-loop pause) shows up as steps. --png
  also writes docs/graph.png via mermaid.ink (opt-in: a network call).
- Presentation: new slide "The graph, as LangGraph draws it" after Stage 4,
  with the compiled graph rendered at high resolution.
- README: links the diagrams and the export command, and says where to see
  the graph in LangSmith (LangGraph runs, Threads tab).

Co-Authored-By: Claude Opus 5.5 <noreply@anthropic.com>
</commit_message>
<xml_diff>
--- a/docs/presentation.pptx
+++ b/docs/presentation.pptx
@@ -15,6 +15,7 @@
     <p:sldId id="263" r:id="rId9"/>
     <p:sldId id="264" r:id="rId10"/>
     <p:sldId id="265" r:id="rId11"/>
+    <p:sldId id="268" r:id="rId19"/>
     <p:sldId id="266" r:id="rId12"/>
     <p:sldId id="267" r:id="rId13"/>
   </p:sldIdLst>
@@ -3973,6 +3974,302 @@
 </p:sld>
 </file>
 
+<file path=ppt/slides/slide13.xml><?xml version="1.0" encoding="utf-8"?>
+<p:sld xmlns:a="http://schemas.openxmlformats.org/drawingml/2006/main" xmlns:r="http://schemas.openxmlformats.org/officeDocument/2006/relationships" xmlns:p="http://schemas.openxmlformats.org/presentationml/2006/main">
+  <p:cSld name="Slide 10">
+    <p:bg>
+      <p:bgPr>
+        <a:solidFill>
+          <a:schemeClr val="bg1"/>
+        </a:solidFill>
+      </p:bgPr>
+    </p:bg>
+    <p:spTree>
+      <p:nvGrpSpPr>
+        <p:cNvPr id="1" name=""/>
+        <p:cNvGrpSpPr/>
+        <p:nvPr/>
+      </p:nvGrpSpPr>
+      <p:grpSpPr>
+        <a:xfrm>
+          <a:off x="0" y="0"/>
+          <a:ext cx="0" cy="0"/>
+          <a:chOff x="0" y="0"/>
+          <a:chExt cx="0" cy="0"/>
+        </a:xfrm>
+      </p:grpSpPr>
+      <p:sp>
+        <p:nvSpPr>
+          <p:cNvPr id="2" name="Text 0"/>
+          <p:cNvSpPr txBox="1"/>
+          <p:nvPr/>
+        </p:nvSpPr>
+        <p:spPr>
+          <a:xfrm>
+            <a:off x="548640" y="457200"/>
+            <a:ext cx="9144000" cy="320040"/>
+          </a:xfrm>
+          <a:prstGeom prst="rect">
+            <a:avLst/>
+          </a:prstGeom>
+          <a:noFill/>
+          <a:ln/>
+        </p:spPr>
+        <p:txBody>
+          <a:bodyPr wrap="square" lIns="0" tIns="0" rIns="0" bIns="0" rtlCol="0" anchor="ctr"/>
+          <a:lstStyle/>
+          <a:p>
+            <a:pPr indent="0" marL="0">
+              <a:buNone/>
+            </a:pPr>
+            <a:r>
+              <a:rPr lang="en-US" sz="1200" b="1" spc="200" kern="0" dirty="0">
+                <a:solidFill>
+                  <a:schemeClr val="accent1"/>
+                </a:solidFill>
+                <a:latin typeface="Calibri" pitchFamily="34" charset="0"/>
+                <a:ea typeface="Calibri" pitchFamily="34" charset="-122"/>
+                <a:cs typeface="Calibri" pitchFamily="34" charset="-120"/>
+              </a:rPr>
+              <a:t>STAGE 4</a:t>
+            </a:r>
+            <a:endParaRPr lang="en-US" sz="1200" dirty="0"/>
+          </a:p>
+        </p:txBody>
+      </p:sp>
+      <p:sp>
+        <p:nvSpPr>
+          <p:cNvPr id="3" name="Text 1"/>
+          <p:cNvSpPr txBox="1"/>
+          <p:nvPr/>
+        </p:nvSpPr>
+        <p:spPr>
+          <a:xfrm>
+            <a:off x="548640" y="777240"/>
+            <a:ext cx="11091672" cy="731520"/>
+          </a:xfrm>
+          <a:prstGeom prst="rect">
+            <a:avLst/>
+          </a:prstGeom>
+          <a:noFill/>
+          <a:ln/>
+        </p:spPr>
+        <p:txBody>
+          <a:bodyPr wrap="square" lIns="0" tIns="0" rIns="0" bIns="0" rtlCol="0" anchor="ctr"/>
+          <a:lstStyle/>
+          <a:p>
+            <a:pPr indent="0" marL="0">
+              <a:buNone/>
+            </a:pPr>
+            <a:r>
+              <a:rPr lang="en-US" sz="3000" b="1" dirty="0">
+                <a:solidFill>
+                  <a:schemeClr val="tx1"/>
+                </a:solidFill>
+                <a:latin typeface="Cambria" pitchFamily="34" charset="0"/>
+                <a:ea typeface="Cambria" pitchFamily="34" charset="-122"/>
+                <a:cs typeface="Cambria" pitchFamily="34" charset="-120"/>
+              </a:rPr>
+              <a:t>The graph, as LangGraph draws it</a:t>
+            </a:r>
+            <a:endParaRPr lang="en-US" sz="3000" dirty="0"/>
+          </a:p>
+        </p:txBody>
+      </p:sp>
+      <p:sp>
+        <p:nvSpPr>
+          <p:cNvPr id="4" name="Text 2"/>
+          <p:cNvSpPr txBox="1"/>
+          <p:nvPr/>
+        </p:nvSpPr>
+        <p:spPr>
+          <a:xfrm>
+            <a:off x="548640" y="1600200"/>
+            <a:ext cx="11091672" cy="640080"/>
+          </a:xfrm>
+          <a:prstGeom prst="rect">
+            <a:avLst/>
+          </a:prstGeom>
+          <a:noFill/>
+          <a:ln/>
+        </p:spPr>
+        <p:txBody>
+          <a:bodyPr wrap="square" lIns="0" tIns="0" rIns="0" bIns="0" rtlCol="0" anchor="ctr"/>
+          <a:lstStyle/>
+          <a:p>
+            <a:pPr indent="0" marL="0">
+              <a:lnSpc>
+                <a:spcPct val="130000"/>
+              </a:lnSpc>
+              <a:buNone/>
+            </a:pPr>
+            <a:r>
+              <a:rPr lang="en-US" sz="1400" dirty="0">
+                <a:solidFill>
+                  <a:schemeClr val="tx2"/>
+                </a:solidFill>
+                <a:latin typeface="Calibri" pitchFamily="34" charset="0"/>
+                <a:ea typeface="Calibri" pitchFamily="34" charset="-122"/>
+                <a:cs typeface="Calibri" pitchFamily="34" charset="-120"/>
+              </a:rPr>
+              <a:t>Rendered from the compiled graph itself, not drawn by hand. Solid arrows are fixed edges; dotted ones are conditional: after confirm, user_agent routes to admin - any other turn ends.</a:t>
+            </a:r>
+            <a:endParaRPr lang="en-US" sz="1400" dirty="0"/>
+          </a:p>
+        </p:txBody>
+      </p:sp>
+      <p:sp>
+        <p:nvSpPr>
+          <p:cNvPr id="16" name="Text 14"/>
+          <p:cNvSpPr txBox="1"/>
+          <p:nvPr/>
+        </p:nvSpPr>
+        <p:spPr>
+          <a:xfrm>
+            <a:off x="548640" y="4846320"/>
+            <a:ext cx="11091672" cy="731520"/>
+          </a:xfrm>
+          <a:prstGeom prst="rect">
+            <a:avLst/>
+          </a:prstGeom>
+          <a:noFill/>
+          <a:ln/>
+        </p:spPr>
+        <p:txBody>
+          <a:bodyPr wrap="square" lIns="0" tIns="0" rIns="0" bIns="0" rtlCol="0" anchor="ctr"/>
+          <a:lstStyle/>
+          <a:p>
+            <a:pPr indent="0" marL="0">
+              <a:lnSpc>
+                <a:spcPct val="130000"/>
+              </a:lnSpc>
+              <a:buNone/>
+            </a:pPr>
+            <a:r>
+              <a:rPr lang="en-US" sz="1300" i="1" dirty="0">
+                <a:solidFill>
+                  <a:schemeClr val="tx2"/>
+                </a:solidFill>
+                <a:latin typeface="Calibri" pitchFamily="34" charset="0"/>
+                <a:ea typeface="Calibri" pitchFamily="34" charset="-122"/>
+                <a:cs typeface="Calibri" pitchFamily="34" charset="-120"/>
+              </a:rPr>
+              <a:t>docs/graph.md also has the user and admin agents' own graphs, where middleware - history summarization, the human-in-the-loop pause - shows up as steps. Regenerate with python -m scripts.export_graph.</a:t>
+            </a:r>
+            <a:endParaRPr lang="en-US" sz="1300" dirty="0"/>
+          </a:p>
+        </p:txBody>
+      </p:sp>
+      <p:sp>
+        <p:nvSpPr>
+          <p:cNvPr id="17" name="Text 15"/>
+          <p:cNvSpPr txBox="1"/>
+          <p:nvPr/>
+        </p:nvSpPr>
+        <p:spPr>
+          <a:xfrm>
+            <a:off x="548640" y="6473952"/>
+            <a:ext cx="6400800" cy="274320"/>
+          </a:xfrm>
+          <a:prstGeom prst="rect">
+            <a:avLst/>
+          </a:prstGeom>
+          <a:noFill/>
+          <a:ln/>
+        </p:spPr>
+        <p:txBody>
+          <a:bodyPr wrap="square" lIns="0" tIns="0" rIns="0" bIns="0" rtlCol="0" anchor="ctr"/>
+          <a:lstStyle/>
+          <a:p>
+            <a:pPr indent="0" marL="0">
+              <a:buNone/>
+            </a:pPr>
+            <a:r>
+              <a:rPr lang="en-US" sz="1000" dirty="0">
+                <a:solidFill>
+                  <a:schemeClr val="tx2"/>
+                </a:solidFill>
+                <a:latin typeface="Calibri" pitchFamily="34" charset="0"/>
+                <a:ea typeface="Calibri" pitchFamily="34" charset="-122"/>
+                <a:cs typeface="Calibri" pitchFamily="34" charset="-120"/>
+              </a:rPr>
+              <a:t>scripts/export_graph.py · docs/graph.md</a:t>
+            </a:r>
+            <a:endParaRPr lang="en-US" sz="1000" dirty="0"/>
+          </a:p>
+        </p:txBody>
+      </p:sp>
+      <p:sp>
+        <p:nvSpPr>
+          <p:cNvPr id="18" name="Text 16"/>
+          <p:cNvSpPr txBox="1"/>
+          <p:nvPr/>
+        </p:nvSpPr>
+        <p:spPr>
+          <a:xfrm>
+            <a:off x="8897112" y="6473952"/>
+            <a:ext cx="2743200" cy="274320"/>
+          </a:xfrm>
+          <a:prstGeom prst="rect">
+            <a:avLst/>
+          </a:prstGeom>
+          <a:noFill/>
+          <a:ln/>
+        </p:spPr>
+        <p:txBody>
+          <a:bodyPr wrap="square" lIns="0" tIns="0" rIns="0" bIns="0" rtlCol="0" anchor="ctr"/>
+          <a:lstStyle/>
+          <a:p>
+            <a:pPr algn="r" indent="0" marL="0">
+              <a:buNone/>
+            </a:pPr>
+            <a:r>
+              <a:rPr lang="en-US" sz="1000" dirty="0">
+                <a:solidFill>
+                  <a:schemeClr val="tx2"/>
+                </a:solidFill>
+                <a:latin typeface="Calibri" pitchFamily="34" charset="0"/>
+                <a:ea typeface="Calibri" pitchFamily="34" charset="-122"/>
+                <a:cs typeface="Calibri" pitchFamily="34" charset="-120"/>
+              </a:rPr>
+              <a:t>VilniusPark Chatbot</a:t>
+            </a:r>
+            <a:endParaRPr lang="en-US" sz="1000" dirty="0"/>
+          </a:p>
+        </p:txBody>
+      </p:sp>
+      <p:pic>
+        <p:nvPicPr>
+          <p:cNvPr id="30" name="ParkingGraph diagram" descr="ParkingGraph rendered by LangGraph: start, user_agent, then either end or admin, record, notification, end"/>
+          <p:cNvPicPr>
+            <a:picLocks noChangeAspect="1"/>
+          </p:cNvPicPr>
+          <p:nvPr/>
+        </p:nvPicPr>
+        <p:blipFill>
+          <a:blip r:embed="rIdGraph"/>
+          <a:stretch>
+            <a:fillRect/>
+          </a:stretch>
+        </p:blipFill>
+        <p:spPr>
+          <a:xfrm>
+            <a:off x="548640" y="2854625"/>
+            <a:ext cx="11091672" cy="1423069"/>
+          </a:xfrm>
+          <a:prstGeom prst="rect">
+            <a:avLst/>
+          </a:prstGeom>
+        </p:spPr>
+      </p:pic>
+    </p:spTree>
+  </p:cSld>
+  <p:clrMapOvr>
+    <a:masterClrMapping/>
+  </p:clrMapOvr>
+</p:sld>
+</file>
+
 <file path=ppt/slides/slide2.xml><?xml version="1.0" encoding="utf-8"?>
 <p:sld xmlns:a="http://schemas.openxmlformats.org/drawingml/2006/main" xmlns:r="http://schemas.openxmlformats.org/officeDocument/2006/relationships" xmlns:p="http://schemas.openxmlformats.org/presentationml/2006/main">
   <p:cSld name="Slide 2">

</xml_diff>

<commit_message>
SEARCH_TYPE setting and a harder 30-question golden set
Search
- SEARCH_TYPE: hybrid (default), semantic (embeddings only) or keyword
  (BM25 only, no embedding call), as a SearchType enum.
- Milvus field names (text, vector, sparse) moved to app/constants;
  DENSE_WEIGHT renamed SEMANTIC_WEIGHT.

Evaluation
- 15 harder questions the system was never tuned on: paraphrases,
  multi-fact, not in the docs, out of scope, private data, injection -
  each with a category and an expected behaviour (answer / decline).
- Retrieval metrics use only the questions with a relevant doc.
- Evidently: grounding checks on questions to answer only; declining is
  the pass where it should decline; per-category and overall pass rates.

Latest run: 67% of 30 questions pass every check. Reviewing the failures,
2 are real bugs (wrong EV bay count for the Airport, Užupis accessible
spaces missed) and 7 are judge errors.

Co-Authored-By: Claude Opus 5.5 <noreply@anthropic.com>
</commit_message>
<xml_diff>
--- a/docs/presentation.pptx
+++ b/docs/presentation.pptx
@@ -2940,7 +2940,7 @@
                 <a:ea typeface="Cambria" pitchFamily="34" charset="-122"/>
                 <a:cs typeface="Cambria" pitchFamily="34" charset="-120"/>
               </a:rPr>
-              <a:t>161</a:t>
+              <a:t>166</a:t>
             </a:r>
             <a:endParaRPr lang="en-US" sz="4000" dirty="0"/>
           </a:p>
@@ -3248,7 +3248,7 @@
                 <a:ea typeface="Calibri" pitchFamily="34" charset="-122"/>
                 <a:cs typeface="Calibri" pitchFamily="34" charset="-120"/>
               </a:rPr>
-              <a:t>15-question golden set</a:t>
+              <a:t>15 single-fact questions</a:t>
             </a:r>
             <a:endParaRPr lang="en-US" sz="1150" dirty="0"/>
           </a:p>
@@ -3441,7 +3441,7 @@
                 <a:ea typeface="Calibri" pitchFamily="34" charset="-122"/>
                 <a:cs typeface="Calibri" pitchFamily="34" charset="-120"/>
               </a:rPr>
-              <a:t>evals/report.md: hybrid search (vector + BM25): Recall@3 1.00, right doc first 87% (MRR 0.92); Evidently judges: faithful 93%, complete 93%, no PII</a:t>
+              <a:t>evals/report.md: 30 questions incl. 15 hard ones; Evidently: 67% pass every check, no PII; reviewing failures found 2 real bugs, 7 judge errors</a:t>
             </a:r>
             <a:endParaRPr lang="en-US" sz="1350" dirty="0"/>
           </a:p>

</xml_diff>